<commit_message>
Align Workbench with TWC 2024x source truth
</commit_message>
<xml_diff>
--- a/Presentation/TWC_WorkbenchV2_How_It_Works.pptx
+++ b/Presentation/TWC_WorkbenchV2_How_It_Works.pptx
@@ -2,25 +2,25 @@
 <file path=ppt/presentation.xml><?xml version="1.0" encoding="utf-8"?>
 <p:presentation xmlns:p="http://schemas.openxmlformats.org/presentationml/2006/main">
   <p:sldMasterIdLst>
-    <p:sldMasterId xmlns:r="http://schemas.openxmlformats.org/officeDocument/2006/relationships" id="2147483648" r:id="R00eb799a6a814ed4"/>
+    <p:sldMasterId xmlns:r="http://schemas.openxmlformats.org/officeDocument/2006/relationships" id="2147483648" r:id="R5d442662001a461a"/>
   </p:sldMasterIdLst>
   <p:notesMasterIdLst>
-    <p:notesMasterId xmlns:r="http://schemas.openxmlformats.org/officeDocument/2006/relationships" r:id="R70d75243d6114ed7"/>
+    <p:notesMasterId xmlns:r="http://schemas.openxmlformats.org/officeDocument/2006/relationships" r:id="R98af82ba74ae418a"/>
   </p:notesMasterIdLst>
   <p:sldIdLst>
-    <p:sldId xmlns:r="http://schemas.openxmlformats.org/officeDocument/2006/relationships" id="256" r:id="R9cf3ac5a3e744d85"/>
-    <p:sldId xmlns:r="http://schemas.openxmlformats.org/officeDocument/2006/relationships" id="257" r:id="Rb3eb06e26e494d14"/>
-    <p:sldId xmlns:r="http://schemas.openxmlformats.org/officeDocument/2006/relationships" id="258" r:id="Rfd5853f9669042da"/>
-    <p:sldId xmlns:r="http://schemas.openxmlformats.org/officeDocument/2006/relationships" id="259" r:id="R1602d9d33f894ffc"/>
-    <p:sldId xmlns:r="http://schemas.openxmlformats.org/officeDocument/2006/relationships" id="260" r:id="R9e5e05e1bf9c4914"/>
-    <p:sldId xmlns:r="http://schemas.openxmlformats.org/officeDocument/2006/relationships" id="261" r:id="R7dacce22a2a44cb9"/>
-    <p:sldId xmlns:r="http://schemas.openxmlformats.org/officeDocument/2006/relationships" id="262" r:id="Rdaf4f35c4a2f4eb1"/>
-    <p:sldId xmlns:r="http://schemas.openxmlformats.org/officeDocument/2006/relationships" id="263" r:id="Rff7cdffc30214ec1"/>
-    <p:sldId xmlns:r="http://schemas.openxmlformats.org/officeDocument/2006/relationships" id="264" r:id="R63dc1f6807e84925"/>
-    <p:sldId xmlns:r="http://schemas.openxmlformats.org/officeDocument/2006/relationships" id="265" r:id="R007c935c113141ed"/>
-    <p:sldId xmlns:r="http://schemas.openxmlformats.org/officeDocument/2006/relationships" id="266" r:id="R90c86fab4d754ed0"/>
-    <p:sldId xmlns:r="http://schemas.openxmlformats.org/officeDocument/2006/relationships" id="267" r:id="R2b3953ec022d4e9f"/>
-    <p:sldId xmlns:r="http://schemas.openxmlformats.org/officeDocument/2006/relationships" id="268" r:id="Rc8312b691dc8451a"/>
+    <p:sldId xmlns:r="http://schemas.openxmlformats.org/officeDocument/2006/relationships" id="256" r:id="R87fe67ce535942a7"/>
+    <p:sldId xmlns:r="http://schemas.openxmlformats.org/officeDocument/2006/relationships" id="257" r:id="Ra8ae08177f644af4"/>
+    <p:sldId xmlns:r="http://schemas.openxmlformats.org/officeDocument/2006/relationships" id="258" r:id="R8bab446799fa4254"/>
+    <p:sldId xmlns:r="http://schemas.openxmlformats.org/officeDocument/2006/relationships" id="259" r:id="Re9462a9923f64175"/>
+    <p:sldId xmlns:r="http://schemas.openxmlformats.org/officeDocument/2006/relationships" id="260" r:id="Rb8341376e1164357"/>
+    <p:sldId xmlns:r="http://schemas.openxmlformats.org/officeDocument/2006/relationships" id="261" r:id="R00de60fa946c4ad4"/>
+    <p:sldId xmlns:r="http://schemas.openxmlformats.org/officeDocument/2006/relationships" id="262" r:id="R306b9b9262c4444e"/>
+    <p:sldId xmlns:r="http://schemas.openxmlformats.org/officeDocument/2006/relationships" id="263" r:id="R6212f552d9f64d29"/>
+    <p:sldId xmlns:r="http://schemas.openxmlformats.org/officeDocument/2006/relationships" id="264" r:id="R1de2057cad4e4a83"/>
+    <p:sldId xmlns:r="http://schemas.openxmlformats.org/officeDocument/2006/relationships" id="265" r:id="Rec88087b57c24789"/>
+    <p:sldId xmlns:r="http://schemas.openxmlformats.org/officeDocument/2006/relationships" id="266" r:id="Rdbe0c69d46324cec"/>
+    <p:sldId xmlns:r="http://schemas.openxmlformats.org/officeDocument/2006/relationships" id="267" r:id="R18a230463e084e48"/>
+    <p:sldId xmlns:r="http://schemas.openxmlformats.org/officeDocument/2006/relationships" id="268" r:id="R7479625277274d28"/>
   </p:sldIdLst>
   <p:sldSz cx="12191695" cy="6858000"/>
   <p:notesSz cx="6858000" cy="9144000"/>
@@ -799,7 +799,7 @@
           <a:lstStyle xmlns:a="http://schemas.openxmlformats.org/drawingml/2006/main"/>
           <a:p xmlns:a="http://schemas.openxmlformats.org/drawingml/2006/main">
             <a:r>
-              <a:t>The important reality check is that this application is engineered around real components, but the final proof comes from the target environment. Authentication, TLS, redirects, TWC version behavior, and Cameo runtime details all need live validation. The plugin has a real scaffold and packaged outputs, but it should be tested inside the actual Cameo installation. The app also intentionally stays within the verified contract. If new TWC features are needed, they should be added only after the contract or live capture proves the API surface.</a:t>
+              <a:t>The honest boundary is live proof. Automated backend tests and the frontend production build pass, and the expanded source package now includes the official 2024x Refresh3 OIDC contract plus full 2024x Java API class pages. Authentication redirects, TLS, group and role permission payloads, and Cameo runtime behavior still require validation against the target deployment. The plugin must compile with the target Cameo SDK and then complete a real project open, snapshot, permission, and Agent workflow before release.</a:t>
             </a:r>
           </a:p>
         </p:txBody>
@@ -869,7 +869,7 @@
           <a:lstStyle xmlns:a="http://schemas.openxmlformats.org/drawingml/2006/main"/>
           <a:p xmlns:a="http://schemas.openxmlformats.org/drawingml/2006/main">
             <a:r>
-              <a:t>The bottom line is that TWC Workbench V2 is a controlled bridge. For users, it is a clean web workspace. For admins, it centralizes server presets, authentication behavior, secure sessions, and verified API boundaries. For automation, it exposes a scoped Developer API and receives rich data from the Cameo plugin. That combination gives the project a practical enterprise path: secure frontend, server-controlled TWC access, cache-first model workflows, and plugin-powered ingestion.</a:t>
+              <a:t>The bottom line is that TWC Workbench V2 is a controlled bridge. Users receive a complete stored Cameo tree and native specification data within their TWC-derived access. Administrators manage server presets, OIDC configuration, background permission inventory, and operational status. Automation uses scoped Developer APIs. Every mapped Open WebUI model receives the complete fingerprinted, size-segmented Workbench and official 3DS reference set plus the current user's permission-scoped branch source, with instructions not to invent unsupported product or model facts.</a:t>
             </a:r>
           </a:p>
         </p:txBody>
@@ -1079,7 +1079,7 @@
           <a:lstStyle xmlns:a="http://schemas.openxmlformats.org/drawingml/2006/main"/>
           <a:p xmlns:a="http://schemas.openxmlformats.org/drawingml/2006/main">
             <a:r>
-              <a:t>The normal sign-in flow starts on the landing page with preset server selection. When the user clicks Sign In via TWC, the backend builds a server-specific authorization URL and redirects the browser to the TWC Authentication Server. After login, the browser returns to the Workbench callback. The backend exchanges the code for tokens and validates the user against Teamwork Cloud. The result is a secure Workbench session. There is also an explicit token fallback for environments where direct AuthServer flow needs troubleshooting.</a:t>
+              <a:t>The normal sign-in flow starts with preset server selection. Workbench reads the selected Authentication Server's 2024x Refresh3 OpenID Connect discovery document and redirects to its authorization endpoint with scope openid. The browser returns to the exact registered Workbench redirect URI. The backend requires matching state, exchanges the code at the discovered token endpoint using client_secret_basic, and validates the returned ID token against Teamwork Cloud. SAML may remain upstream of AuthServer as the enterprise identity provider, but Workbench itself is an OIDC client. Explicit token sign-in remains available for troubleshooting.</a:t>
             </a:r>
           </a:p>
         </p:txBody>
@@ -1699,8 +1699,8 @@
   </p:cSld>
   <p:clrMap bg1="lt1" tx1="dk1" bg2="lt2" tx2="dk2" accent1="accent1" accent2="accent2" accent3="accent3" accent4="accent4" accent5="accent5" accent6="accent6" hlink="hlink" folHlink="folHlink"/>
   <p:sldLayoutIdLst>
-    <p:sldLayoutId xmlns:r="http://schemas.openxmlformats.org/officeDocument/2006/relationships" id="2147483649" r:id="R474af9ea20d44299"/>
-    <p:sldLayoutId xmlns:r="http://schemas.openxmlformats.org/officeDocument/2006/relationships" id="2147483650" r:id="Rb88a6ac734704f3a"/>
+    <p:sldLayoutId xmlns:r="http://schemas.openxmlformats.org/officeDocument/2006/relationships" id="2147483649" r:id="Rbf6f76b74d4542c8"/>
+    <p:sldLayoutId xmlns:r="http://schemas.openxmlformats.org/officeDocument/2006/relationships" id="2147483650" r:id="Re31f9db29446423f"/>
   </p:sldLayoutIdLst>
   <p:hf sldNum="0" hdr="0" ftr="0" dt="0"/>
   <p:txStyles>
@@ -5584,7 +5584,7 @@
                 <a:ea typeface="Aptos"/>
                 <a:cs typeface="Aptos"/>
               </a:rPr>
-              <a:t>Backend and frontend builds pass. The persistent reference resolves 456 official 3DS pages and 857 chunks. Enterprise TWC/AuthServer and TLS still need live proof.</a:t>
+              <a:t>Backend tests and frontend build pass. The expanded reference includes official 2024x R3 docs and full 2024x Java API pages. Enterprise TWC/AuthServer, permissions, and TLS still need live proof.</a:t>
             </a:r>
           </a:p>
         </p:txBody>
@@ -5718,7 +5718,7 @@
                 <a:ea typeface="Aptos"/>
                 <a:cs typeface="Aptos"/>
               </a:rPr>
-              <a:t>The exporter follows official 2024x metamodel and TagsHelper APIs. It still needs compilation and end-to-end capture inside the target Cameo runtime.</a:t>
+              <a:t>The exporter is implemented against documented 2024x metamodel and TagsHelper APIs. It still needs SDK compilation and end-to-end capture inside the target Cameo runtime.</a:t>
             </a:r>
           </a:p>
         </p:txBody>
@@ -6502,7 +6502,7 @@
                 <a:ea typeface="Aptos"/>
                 <a:cs typeface="Aptos"/>
               </a:rPr>
-              <a:t>Scoped APIs plus two processed Agent sources make the model usable by scripts and any mapped OWUI model.</a:t>
+              <a:t>Scoped APIs plus a segmented 3DS reference set and branch source ground scripts and any mapped OWUI model.</a:t>
             </a:r>
           </a:p>
         </p:txBody>
@@ -8064,7 +8064,7 @@
         </p:spPr>
         <p:txBody>
           <a:bodyPr xmlns:a="http://schemas.openxmlformats.org/drawingml/2006/main" wrap="square" lIns="254" tIns="254" rIns="254" bIns="254" anchor="t">
-            <a:normAutofit/>
+            <a:normAutofit fontScale="56984"/>
           </a:bodyPr>
           <a:lstStyle xmlns:a="http://schemas.openxmlformats.org/drawingml/2006/main"/>
           <a:p xmlns:a="http://schemas.openxmlformats.org/drawingml/2006/main">
@@ -8080,7 +8080,7 @@
                 <a:ea typeface="Aptos"/>
                 <a:cs typeface="Aptos"/>
               </a:rPr>
-              <a:t>SAML/AuthServer code flow</a:t>
+              <a:t>OIDC code flow</a:t>
             </a:r>
           </a:p>
           <a:p xmlns:a="http://schemas.openxmlformats.org/drawingml/2006/main">
@@ -9789,7 +9789,7 @@
         </p:spPr>
         <p:txBody>
           <a:bodyPr xmlns:a="http://schemas.openxmlformats.org/drawingml/2006/main" wrap="square" lIns="254" tIns="254" rIns="254" bIns="254" anchor="t">
-            <a:normAutofit/>
+            <a:normAutofit fontScale="100000"/>
           </a:bodyPr>
           <a:lstStyle xmlns:a="http://schemas.openxmlformats.org/drawingml/2006/main"/>
           <a:p xmlns:a="http://schemas.openxmlformats.org/drawingml/2006/main">
@@ -10036,7 +10036,7 @@
         </p:spPr>
         <p:txBody>
           <a:bodyPr xmlns:a="http://schemas.openxmlformats.org/drawingml/2006/main" wrap="square" lIns="254" tIns="254" rIns="254" bIns="254" anchor="t">
-            <a:normAutofit/>
+            <a:normAutofit fontScale="100000"/>
           </a:bodyPr>
           <a:lstStyle xmlns:a="http://schemas.openxmlformats.org/drawingml/2006/main"/>
           <a:p xmlns:a="http://schemas.openxmlformats.org/drawingml/2006/main">
@@ -12166,7 +12166,7 @@
         </p:spPr>
         <p:txBody>
           <a:bodyPr xmlns:a="http://schemas.openxmlformats.org/drawingml/2006/main" wrap="square" lIns="254" tIns="254" rIns="254" bIns="254" anchor="t">
-            <a:normAutofit/>
+            <a:normAutofit fontScale="100000"/>
           </a:bodyPr>
           <a:lstStyle xmlns:a="http://schemas.openxmlformats.org/drawingml/2006/main"/>
           <a:p xmlns:a="http://schemas.openxmlformats.org/drawingml/2006/main">
@@ -12182,7 +12182,7 @@
                 <a:ea typeface="Aptos"/>
                 <a:cs typeface="Aptos"/>
               </a:rPr>
-              <a:t>• /auth: session, signin, callback, token login, OSLC auth</a:t>
+              <a:t>• /auth: OIDC signin, callback, session, token fallback</a:t>
             </a:r>
           </a:p>
           <a:p xmlns:a="http://schemas.openxmlformats.org/drawingml/2006/main">
@@ -12214,7 +12214,7 @@
                 <a:ea typeface="Aptos"/>
                 <a:cs typeface="Aptos"/>
               </a:rPr>
-              <a:t>• /workspace: projects, tree, items, compare, cache sync, agent</a:t>
+              <a:t>• /workspace: projects, tree, items, compare, permissions, agent</a:t>
             </a:r>
           </a:p>
           <a:p xmlns:a="http://schemas.openxmlformats.org/drawingml/2006/main">
@@ -12230,7 +12230,7 @@
                 <a:ea typeface="Aptos"/>
                 <a:cs typeface="Aptos"/>
               </a:rPr>
-              <a:t>• /cache: cache manifest, branch data, elements, graph, edits</a:t>
+              <a:t>• /cache: scoped branch data, elements, graph, and edits</a:t>
             </a:r>
           </a:p>
         </p:txBody>

</xml_diff>